<commit_message>
Fix CSV upload/template timeouts and show ML results after SME upload
Score with the lender-facing model immediately after import, retrain in the background, surface row errors, align export columns, remove admin ML metrics UI, and humanize the technical report and defence deck.

Co-authored-by: Cursor <cursoragent@cursor.com>
</commit_message>
<xml_diff>
--- a/Presentation/Ushirika_Group15_Defence_v13.pptx
+++ b/Presentation/Ushirika_Group15_Defence_v13.pptx
@@ -6099,7 +6099,7 @@
                 </a:solidFill>
                 <a:latin typeface="Georgia"/>
               </a:rPr>
-              <a:t>The problem this project set out to solve</a:t>
+              <a:t>Why Tanzanian SMEs still struggle to get fair credit</a:t>
             </a:r>
           </a:p>
         </p:txBody>
@@ -7261,7 +7261,7 @@
                 </a:solidFill>
                 <a:latin typeface="Georgia"/>
               </a:rPr>
-              <a:t>General objective and three specific objectives</a:t>
+              <a:t>What we set out to build — in clear terms</a:t>
             </a:r>
           </a:p>
         </p:txBody>
@@ -8185,7 +8185,7 @@
                 </a:solidFill>
                 <a:latin typeface="Georgia"/>
               </a:rPr>
-              <a:t>Ushirika — end-to-end SME value-chain credit platform</a:t>
+              <a:t>Ushirika — a working credit platform for SMEs and lenders</a:t>
             </a:r>
           </a:p>
         </p:txBody>
@@ -10485,7 +10485,7 @@
                 </a:solidFill>
                 <a:latin typeface="Georgia"/>
               </a:rPr>
-              <a:t>A controlled train–test design — not a hard-coded score table</a:t>
+              <a:t>How we trained and tested the models fairly</a:t>
             </a:r>
           </a:p>
         </p:txBody>

</xml_diff>

<commit_message>
Document deploy-on-update workflow and refresh defence PPT.
Always sync GitHub, Vercel, Render, and the Group 15 deck after product changes; bump Render deploy trigger for API v1.3.2.

Co-authored-by: Cursor <cursoragent@cursor.com>
</commit_message>
<xml_diff>
--- a/Presentation/Ushirika_Group15_Defence_v13.pptx
+++ b/Presentation/Ushirika_Group15_Defence_v13.pptx
@@ -8422,7 +8422,7 @@
                 </a:solidFill>
                 <a:latin typeface="Calibri"/>
               </a:rPr>
-              <a:t>Per-SME ML metrics</a:t>
+              <a:t>Tabbed lender detail</a:t>
             </a:r>
           </a:p>
           <a:p>
@@ -8438,7 +8438,7 @@
                 </a:solidFill>
                 <a:latin typeface="Calibri"/>
               </a:rPr>
-              <a:t>on lender detail</a:t>
+              <a:t>EN / Kiswahili UI</a:t>
             </a:r>
           </a:p>
         </p:txBody>
@@ -9149,7 +9149,23 @@
                 </a:solidFill>
                 <a:latin typeface="Calibri"/>
               </a:rPr>
-              <a:t>Outlier-aware financing</a:t>
+              <a:t>25% outlier rule</a:t>
+            </a:r>
+          </a:p>
+          <a:p>
+            <a:pPr algn="ctr">
+              <a:spcAft>
+                <a:spcPts val="300"/>
+              </a:spcAft>
+            </a:pPr>
+            <a:r>
+              <a:rPr sz="1300" b="0">
+                <a:solidFill>
+                  <a:srgbClr val="0F2830"/>
+                </a:solidFill>
+                <a:latin typeface="Calibri"/>
+              </a:rPr>
+              <a:t>Conservative loans</a:t>
             </a:r>
           </a:p>
         </p:txBody>
@@ -9204,7 +9220,7 @@
                 </a:solidFill>
                 <a:latin typeface="Calibri"/>
               </a:rPr>
-              <a:t>Lender workflow: select an SME → see ML score, creditworthy probability, and feature signals from that SME’s data.</a:t>
+              <a:t>Lender workflow: progressive NIDA search → SME profile (incl. TIN) → tabs for ML metrics, signals, txs, history.</a:t>
             </a:r>
           </a:p>
         </p:txBody>
@@ -10706,7 +10722,7 @@
                 </a:solidFill>
                 <a:latin typeface="Calibri"/>
               </a:rPr>
-              <a:t>•  Outliers are flagged; financing caps use typical volume, not one-off spikes.</a:t>
+              <a:t>•  Outlier rule: rare large deals (&lt;25% of txs) are excluded from loan sizing; frequent large deals count as pattern.</a:t>
             </a:r>
           </a:p>
         </p:txBody>
@@ -12226,7 +12242,7 @@
                 </a:solidFill>
                 <a:latin typeface="Calibri"/>
               </a:rPr>
-              <a:t>IQR flags unusual large deals for lending caps</a:t>
+              <a:t>25% frequency guard: rare spikes excluded from loan; pattern large deals kept</a:t>
             </a:r>
           </a:p>
         </p:txBody>
@@ -13881,7 +13897,7 @@
                 </a:solidFill>
                 <a:latin typeface="Calibri"/>
               </a:rPr>
-              <a:t>•  Financing never exceeds typical (non-outlier) capacity — realistic lending.</a:t>
+              <a:t>•  Financing capped at ~50% of typical (non-outlier) volume — reduces unpaid-loan risk.</a:t>
             </a:r>
           </a:p>
           <a:p>
@@ -14045,7 +14061,7 @@
                 </a:solidFill>
                 <a:latin typeface="Calibri"/>
               </a:rPr>
-              <a:t>•  Eligible financing (TZS) with outlier-aware caps.</a:t>
+              <a:t>•  Eligible financing (TZS) with 25% outlier-aware caps.</a:t>
             </a:r>
           </a:p>
           <a:p>
@@ -14064,7 +14080,7 @@
                 </a:solidFill>
                 <a:latin typeface="Calibri"/>
               </a:rPr>
-              <a:t>•  Human-readable score components for explainability.</a:t>
+              <a:t>•  Crucial score signals only (not every engineered feature).</a:t>
             </a:r>
           </a:p>
           <a:p>
@@ -14083,7 +14099,7 @@
                 </a:solidFill>
                 <a:latin typeface="Calibri"/>
               </a:rPr>
-              <a:t>•  Lender portfolio view by NIDA / membership ID.</a:t>
+              <a:t>•  Lender: progressive NIDA search + tabbed SME analytics.</a:t>
             </a:r>
           </a:p>
           <a:p>
@@ -14102,7 +14118,7 @@
                 </a:solidFill>
                 <a:latin typeface="Calibri"/>
               </a:rPr>
-              <a:t>•  Admin governance for accounts and PIN reset.</a:t>
+              <a:t>•  TIN shown on SME profile (SME + Lender views).</a:t>
             </a:r>
           </a:p>
           <a:p>
@@ -14121,7 +14137,7 @@
                 </a:solidFill>
                 <a:latin typeface="Calibri"/>
               </a:rPr>
-              <a:t>•  Bilingual portal (English / Kiswahili).</a:t>
+              <a:t>•  Bilingual portal (English / Kiswahili) end-to-end.</a:t>
             </a:r>
           </a:p>
         </p:txBody>

</xml_diff>